<commit_message>
Credit Goal Diggers and add Tuesday inventory with portable manifest preservation
</commit_message>
<xml_diff>
--- a/presentation/WasteSort_Monday_Concepts.pptx
+++ b/presentation/WasteSort_Monday_Concepts.pptx
@@ -2,19 +2,19 @@
 <file path=ppt/presentation.xml><?xml version="1.0" encoding="utf-8"?>
 <p:presentation xmlns:p="http://schemas.openxmlformats.org/presentationml/2006/main">
   <p:sldMasterIdLst>
-    <p:sldMasterId xmlns:r="http://schemas.openxmlformats.org/officeDocument/2006/relationships" id="2147483648" r:id="R9b16ffe9b7a24529"/>
+    <p:sldMasterId xmlns:r="http://schemas.openxmlformats.org/officeDocument/2006/relationships" id="2147483648" r:id="Rfd2682fef5854921"/>
   </p:sldMasterIdLst>
   <p:notesMasterIdLst>
-    <p:notesMasterId xmlns:r="http://schemas.openxmlformats.org/officeDocument/2006/relationships" r:id="R0462cb40e166479a"/>
+    <p:notesMasterId xmlns:r="http://schemas.openxmlformats.org/officeDocument/2006/relationships" r:id="R77d6ba4f63684636"/>
   </p:notesMasterIdLst>
   <p:sldIdLst>
-    <p:sldId xmlns:r="http://schemas.openxmlformats.org/officeDocument/2006/relationships" id="256" r:id="Ree9c8fa743334e60"/>
-    <p:sldId xmlns:r="http://schemas.openxmlformats.org/officeDocument/2006/relationships" id="257" r:id="R5ef2cee19ab14354"/>
-    <p:sldId xmlns:r="http://schemas.openxmlformats.org/officeDocument/2006/relationships" id="258" r:id="R38d895c2c9a842cd"/>
-    <p:sldId xmlns:r="http://schemas.openxmlformats.org/officeDocument/2006/relationships" id="259" r:id="R8f3832f377ee45b2"/>
-    <p:sldId xmlns:r="http://schemas.openxmlformats.org/officeDocument/2006/relationships" id="260" r:id="Rf6a520c6960d42d5"/>
-    <p:sldId xmlns:r="http://schemas.openxmlformats.org/officeDocument/2006/relationships" id="261" r:id="R9c7e487fea00468d"/>
-    <p:sldId xmlns:r="http://schemas.openxmlformats.org/officeDocument/2006/relationships" id="262" r:id="R01643609b94e4ebd"/>
+    <p:sldId xmlns:r="http://schemas.openxmlformats.org/officeDocument/2006/relationships" id="256" r:id="Rf77cfe5230484123"/>
+    <p:sldId xmlns:r="http://schemas.openxmlformats.org/officeDocument/2006/relationships" id="257" r:id="R09410bb606e047f8"/>
+    <p:sldId xmlns:r="http://schemas.openxmlformats.org/officeDocument/2006/relationships" id="258" r:id="Re52be7ba6f5b4b0c"/>
+    <p:sldId xmlns:r="http://schemas.openxmlformats.org/officeDocument/2006/relationships" id="259" r:id="R63e7968d12334252"/>
+    <p:sldId xmlns:r="http://schemas.openxmlformats.org/officeDocument/2006/relationships" id="260" r:id="R7568e60b4fd74b45"/>
+    <p:sldId xmlns:r="http://schemas.openxmlformats.org/officeDocument/2006/relationships" id="261" r:id="Re64561d1762946b9"/>
+    <p:sldId xmlns:r="http://schemas.openxmlformats.org/officeDocument/2006/relationships" id="262" r:id="R6db9eb0e5001451f"/>
   </p:sldIdLst>
   <p:sldSz cx="12192000" cy="6858000"/>
   <p:notesSz cx="6858000" cy="9144000"/>
@@ -448,7 +448,7 @@
           <a:lstStyle xmlns:a="http://schemas.openxmlformats.org/drawingml/2006/main"/>
           <a:p xmlns:a="http://schemas.openxmlformats.org/drawingml/2006/main">
             <a:r>
-              <a:t>Good morning. I’m Lordy Allen Reyes. Today I’ll explain the basic ideas behind our WasteSort project: artificial intelligence, machine learning, the main learning types, and how we use supervised image classification. Our task is to predict the material of one waste item from a photograph. This presentation focuses on the concepts behind that task.</a:t>
+              <a:t>Good morning. We are Goal Diggers. Today we’ll explain the basic ideas behind our WasteSort project: artificial intelligence, machine learning, the main learning types, and how we use supervised image classification. Our task is to predict the material of one waste item from a photograph. This presentation focuses on the concepts behind that task.</a:t>
             </a:r>
           </a:p>
           <a:p xmlns:a="http://schemas.openxmlformats.org/drawingml/2006/main">
@@ -1035,7 +1035,7 @@
           <p:cNvPr id="3" name="Title">
             <a:extLst xmlns:a="http://schemas.openxmlformats.org/drawingml/2006/main">
               <a:ext uri="{FF2B5EF4-FFF2-40B4-BE49-F238E27FC236}">
-                <a16:creationId xmlns:a16="http://schemas.microsoft.com/office/drawing/2014/main" id="{0EA2995C-4BF8-41F1-92EC-250C26C82D7E}"/>
+                <a16:creationId xmlns:a16="http://schemas.microsoft.com/office/drawing/2014/main" id="{A68D95F5-601F-456B-B59F-0ACEE3941400}"/>
               </a:ext>
             </a:extLst>
           </p:cNvPr>
@@ -1264,7 +1264,7 @@
           <p:cNvPr id="2" name="Subtitle">
             <a:extLst xmlns:a="http://schemas.openxmlformats.org/drawingml/2006/main">
               <a:ext uri="{FF2B5EF4-FFF2-40B4-BE49-F238E27FC236}">
-                <a16:creationId xmlns:a16="http://schemas.microsoft.com/office/drawing/2014/main" id="{19549F83-150A-4282-9012-41FD0468F8C2}"/>
+                <a16:creationId xmlns:a16="http://schemas.microsoft.com/office/drawing/2014/main" id="{FEC33703-70DE-4C24-A74F-CD39D51C9735}"/>
               </a:ext>
             </a:extLst>
           </p:cNvPr>
@@ -1510,7 +1510,7 @@
           <p:cNvPr id="2" name="Section title">
             <a:extLst xmlns:a="http://schemas.openxmlformats.org/drawingml/2006/main">
               <a:ext uri="{FF2B5EF4-FFF2-40B4-BE49-F238E27FC236}">
-                <a16:creationId xmlns:a16="http://schemas.microsoft.com/office/drawing/2014/main" id="{D0E7D80C-36D4-44BA-B7AC-179D93FA4739}"/>
+                <a16:creationId xmlns:a16="http://schemas.microsoft.com/office/drawing/2014/main" id="{C97BC80A-C5AF-4352-8B43-02A2BA252C64}"/>
               </a:ext>
             </a:extLst>
           </p:cNvPr>
@@ -1756,7 +1756,7 @@
           <p:cNvPr id="3" name="Title">
             <a:extLst xmlns:a="http://schemas.openxmlformats.org/drawingml/2006/main">
               <a:ext uri="{FF2B5EF4-FFF2-40B4-BE49-F238E27FC236}">
-                <a16:creationId xmlns:a16="http://schemas.microsoft.com/office/drawing/2014/main" id="{9F2AFD96-A356-4EF8-926C-0729A78C348D}"/>
+                <a16:creationId xmlns:a16="http://schemas.microsoft.com/office/drawing/2014/main" id="{A19B19E4-0F9C-45C4-839E-D7EC810FD4FC}"/>
               </a:ext>
             </a:extLst>
           </p:cNvPr>
@@ -1985,7 +1985,7 @@
           <p:cNvPr id="2" name="Body">
             <a:extLst xmlns:a="http://schemas.openxmlformats.org/drawingml/2006/main">
               <a:ext uri="{FF2B5EF4-FFF2-40B4-BE49-F238E27FC236}">
-                <a16:creationId xmlns:a16="http://schemas.microsoft.com/office/drawing/2014/main" id="{0E1ABE97-C233-481F-BA7E-8E3B78FF4185}"/>
+                <a16:creationId xmlns:a16="http://schemas.microsoft.com/office/drawing/2014/main" id="{52A82BA5-D736-4A5A-A637-A78975C98D30}"/>
               </a:ext>
             </a:extLst>
           </p:cNvPr>
@@ -2231,7 +2231,7 @@
           <p:cNvPr id="4" name="Title">
             <a:extLst xmlns:a="http://schemas.openxmlformats.org/drawingml/2006/main">
               <a:ext uri="{FF2B5EF4-FFF2-40B4-BE49-F238E27FC236}">
-                <a16:creationId xmlns:a16="http://schemas.microsoft.com/office/drawing/2014/main" id="{18DC1808-32D5-4F96-8DE8-16B1FD120C32}"/>
+                <a16:creationId xmlns:a16="http://schemas.microsoft.com/office/drawing/2014/main" id="{7991C316-6999-4A84-9239-4851FC3E7B81}"/>
               </a:ext>
             </a:extLst>
           </p:cNvPr>
@@ -2460,7 +2460,7 @@
           <p:cNvPr id="2" name="Left column">
             <a:extLst xmlns:a="http://schemas.openxmlformats.org/drawingml/2006/main">
               <a:ext uri="{FF2B5EF4-FFF2-40B4-BE49-F238E27FC236}">
-                <a16:creationId xmlns:a16="http://schemas.microsoft.com/office/drawing/2014/main" id="{5E308D49-2C18-439F-80EB-EB1813997802}"/>
+                <a16:creationId xmlns:a16="http://schemas.microsoft.com/office/drawing/2014/main" id="{18FE1355-9FF7-4BE7-9994-91053AAE54F0}"/>
               </a:ext>
             </a:extLst>
           </p:cNvPr>
@@ -2689,7 +2689,7 @@
           <p:cNvPr id="3" name="Right column">
             <a:extLst xmlns:a="http://schemas.openxmlformats.org/drawingml/2006/main">
               <a:ext uri="{FF2B5EF4-FFF2-40B4-BE49-F238E27FC236}">
-                <a16:creationId xmlns:a16="http://schemas.microsoft.com/office/drawing/2014/main" id="{C631D41D-23B4-4839-ABA0-38BD9E38EDC8}"/>
+                <a16:creationId xmlns:a16="http://schemas.microsoft.com/office/drawing/2014/main" id="{F8781F4C-BEB2-4C39-96E6-CA1578195FE8}"/>
               </a:ext>
             </a:extLst>
           </p:cNvPr>
@@ -2935,7 +2935,7 @@
           <p:cNvPr id="3" name="Title">
             <a:extLst xmlns:a="http://schemas.openxmlformats.org/drawingml/2006/main">
               <a:ext uri="{FF2B5EF4-FFF2-40B4-BE49-F238E27FC236}">
-                <a16:creationId xmlns:a16="http://schemas.microsoft.com/office/drawing/2014/main" id="{B3AB1C40-1736-4F04-AF0B-CD8516130ED8}"/>
+                <a16:creationId xmlns:a16="http://schemas.microsoft.com/office/drawing/2014/main" id="{CB53ED12-0061-4D0F-A00B-E61FC6A572F6}"/>
               </a:ext>
             </a:extLst>
           </p:cNvPr>
@@ -3164,7 +3164,7 @@
           <p:cNvPr id="2" name="Left column">
             <a:extLst xmlns:a="http://schemas.openxmlformats.org/drawingml/2006/main">
               <a:ext uri="{FF2B5EF4-FFF2-40B4-BE49-F238E27FC236}">
-                <a16:creationId xmlns:a16="http://schemas.microsoft.com/office/drawing/2014/main" id="{2274FFF5-7C6F-46BD-A299-0CB15E023162}"/>
+                <a16:creationId xmlns:a16="http://schemas.microsoft.com/office/drawing/2014/main" id="{14396E29-108D-492D-A845-26740DA4069C}"/>
               </a:ext>
             </a:extLst>
           </p:cNvPr>
@@ -3431,12 +3431,12 @@
   </p:cSld>
   <p:clrMap bg1="lt1" tx1="dk1" bg2="lt2" tx2="dk2" accent1="accent1" accent2="accent2" accent3="accent3" accent4="accent4" accent5="accent5" accent6="accent6" hlink="hlink" folHlink="folHlink"/>
   <p:sldLayoutIdLst>
-    <p:sldLayoutId xmlns:r="http://schemas.openxmlformats.org/officeDocument/2006/relationships" id="2147483649" r:id="R4cfd5b7e33934cac"/>
-    <p:sldLayoutId xmlns:r="http://schemas.openxmlformats.org/officeDocument/2006/relationships" id="2147483650" r:id="Rb69fe920e49443f3"/>
-    <p:sldLayoutId xmlns:r="http://schemas.openxmlformats.org/officeDocument/2006/relationships" id="2147483651" r:id="R2b8923e511ea46a9"/>
-    <p:sldLayoutId xmlns:r="http://schemas.openxmlformats.org/officeDocument/2006/relationships" id="2147483652" r:id="R2cfb2109dada4c0c"/>
-    <p:sldLayoutId xmlns:r="http://schemas.openxmlformats.org/officeDocument/2006/relationships" id="2147483653" r:id="Re81ffc80abcf4673"/>
-    <p:sldLayoutId xmlns:r="http://schemas.openxmlformats.org/officeDocument/2006/relationships" id="2147483654" r:id="R72ceccf8d6324253"/>
+    <p:sldLayoutId xmlns:r="http://schemas.openxmlformats.org/officeDocument/2006/relationships" id="2147483649" r:id="R2e5b9052f7b8471e"/>
+    <p:sldLayoutId xmlns:r="http://schemas.openxmlformats.org/officeDocument/2006/relationships" id="2147483650" r:id="R18c0955819d84479"/>
+    <p:sldLayoutId xmlns:r="http://schemas.openxmlformats.org/officeDocument/2006/relationships" id="2147483651" r:id="R30766939e0d643e9"/>
+    <p:sldLayoutId xmlns:r="http://schemas.openxmlformats.org/officeDocument/2006/relationships" id="2147483652" r:id="Rfdab2d34bc154498"/>
+    <p:sldLayoutId xmlns:r="http://schemas.openxmlformats.org/officeDocument/2006/relationships" id="2147483653" r:id="R64b55944aa85467e"/>
+    <p:sldLayoutId xmlns:r="http://schemas.openxmlformats.org/officeDocument/2006/relationships" id="2147483654" r:id="R6643662af5b943e5"/>
   </p:sldLayoutIdLst>
   <p:txStyles>
     <p:titleStyle>
@@ -3987,7 +3987,7 @@
           <p:cNvPr id="7" name="">
             <a:extLst xmlns:a="http://schemas.openxmlformats.org/drawingml/2006/main">
               <a:ext uri="{FF2B5EF4-FFF2-40B4-BE49-F238E27FC236}">
-                <a16:creationId xmlns:a16="http://schemas.microsoft.com/office/drawing/2014/main" id="{8A33FB9F-29B6-46FB-85C8-FC7BDF2CDDEC}"/>
+                <a16:creationId xmlns:a16="http://schemas.microsoft.com/office/drawing/2014/main" id="{D8928CCF-EDE8-47A2-8C04-DAEABCFFF560}"/>
               </a:ext>
             </a:extLst>
           </p:cNvPr>
@@ -4143,7 +4143,7 @@
           <p:cNvPr id="2" name="">
             <a:extLst xmlns:a="http://schemas.openxmlformats.org/drawingml/2006/main">
               <a:ext uri="{FF2B5EF4-FFF2-40B4-BE49-F238E27FC236}">
-                <a16:creationId xmlns:a16="http://schemas.microsoft.com/office/drawing/2014/main" id="{7E1DAEDC-2700-4D82-90E7-CE69A5BA8485}"/>
+                <a16:creationId xmlns:a16="http://schemas.microsoft.com/office/drawing/2014/main" id="{36E42C78-AD09-4112-9B5A-F3868D639EC4}"/>
               </a:ext>
             </a:extLst>
           </p:cNvPr>
@@ -4299,7 +4299,7 @@
           <p:cNvPr id="3" name="">
             <a:extLst xmlns:a="http://schemas.openxmlformats.org/drawingml/2006/main">
               <a:ext uri="{FF2B5EF4-FFF2-40B4-BE49-F238E27FC236}">
-                <a16:creationId xmlns:a16="http://schemas.microsoft.com/office/drawing/2014/main" id="{183B57AD-27A2-4A00-99AE-2C20058F3571}"/>
+                <a16:creationId xmlns:a16="http://schemas.microsoft.com/office/drawing/2014/main" id="{32522DBE-9CF1-4DD6-9CF7-B68F88A4463C}"/>
               </a:ext>
             </a:extLst>
           </p:cNvPr>
@@ -4455,7 +4455,7 @@
           <p:cNvPr id="4" name="">
             <a:extLst xmlns:a="http://schemas.openxmlformats.org/drawingml/2006/main">
               <a:ext uri="{FF2B5EF4-FFF2-40B4-BE49-F238E27FC236}">
-                <a16:creationId xmlns:a16="http://schemas.microsoft.com/office/drawing/2014/main" id="{E669CD4A-6C80-483D-A6E8-776D8D6B6036}"/>
+                <a16:creationId xmlns:a16="http://schemas.microsoft.com/office/drawing/2014/main" id="{1D46E9C4-CB35-48DA-A684-79E89117A3C5}"/>
               </a:ext>
             </a:extLst>
           </p:cNvPr>
@@ -4611,7 +4611,7 @@
           <p:cNvPr id="5" name="">
             <a:extLst xmlns:a="http://schemas.openxmlformats.org/drawingml/2006/main">
               <a:ext uri="{FF2B5EF4-FFF2-40B4-BE49-F238E27FC236}">
-                <a16:creationId xmlns:a16="http://schemas.microsoft.com/office/drawing/2014/main" id="{2804E0DB-A992-4CC6-BD59-EA6C2A5986B0}"/>
+                <a16:creationId xmlns:a16="http://schemas.microsoft.com/office/drawing/2014/main" id="{17F88042-EB4E-4D9B-9F24-82DCF8472277}"/>
               </a:ext>
             </a:extLst>
           </p:cNvPr>
@@ -4757,7 +4757,7 @@
                 <a:ea typeface="Arial"/>
                 <a:cs typeface="Arial"/>
               </a:rPr>
-              <a:t>Lordy Allen D. Reyes</a:t>
+              <a:t>Goal Diggers</a:t>
             </a:r>
           </a:p>
           <a:p xmlns:a="http://schemas.openxmlformats.org/drawingml/2006/main">
@@ -4790,7 +4790,7 @@
           <p:cNvPr id="6" name="">
             <a:extLst xmlns:a="http://schemas.openxmlformats.org/drawingml/2006/main">
               <a:ext uri="{FF2B5EF4-FFF2-40B4-BE49-F238E27FC236}">
-                <a16:creationId xmlns:a16="http://schemas.microsoft.com/office/drawing/2014/main" id="{3DDAB455-6BB7-49C1-AD8E-F0531E6192E4}"/>
+                <a16:creationId xmlns:a16="http://schemas.microsoft.com/office/drawing/2014/main" id="{1C7D3F48-8BC4-4C3F-AD9F-C7951BB7C609}"/>
               </a:ext>
             </a:extLst>
           </p:cNvPr>
@@ -4800,7 +4800,7 @@
           <p:nvPr/>
         </p:nvPicPr>
         <p:blipFill>
-          <a:blip xmlns:r="http://schemas.openxmlformats.org/officeDocument/2006/relationships" xmlns:a="http://schemas.openxmlformats.org/drawingml/2006/main" r:embed="R425fd15237a84f72"/>
+          <a:blip xmlns:r="http://schemas.openxmlformats.org/officeDocument/2006/relationships" xmlns:a="http://schemas.openxmlformats.org/drawingml/2006/main" r:embed="Rea54a5e20f6a46c0"/>
           <a:stretch xmlns:a="http://schemas.openxmlformats.org/drawingml/2006/main"/>
         </p:blipFill>
         <p:spPr>
@@ -4816,7 +4816,7 @@
     </p:spTree>
     <p:extLst>
       <p:ext uri="{BB962C8B-B14F-4D97-AF65-F5344CB8AC3E}">
-        <p14:creationId xmlns:p14="http://schemas.microsoft.com/office/powerpoint/2010/main" val="424566484"/>
+        <p14:creationId xmlns:p14="http://schemas.microsoft.com/office/powerpoint/2010/main" val="231009659"/>
       </p:ext>
     </p:extLst>
   </p:cSld>
@@ -4847,7 +4847,7 @@
           <p:cNvPr id="8" name="">
             <a:extLst xmlns:a="http://schemas.openxmlformats.org/drawingml/2006/main">
               <a:ext uri="{FF2B5EF4-FFF2-40B4-BE49-F238E27FC236}">
-                <a16:creationId xmlns:a16="http://schemas.microsoft.com/office/drawing/2014/main" id="{0E226C51-F33C-48B4-803E-44D33296E350}"/>
+                <a16:creationId xmlns:a16="http://schemas.microsoft.com/office/drawing/2014/main" id="{677C9137-A848-4667-880F-46FA1488D71A}"/>
               </a:ext>
             </a:extLst>
           </p:cNvPr>
@@ -5003,7 +5003,7 @@
           <p:cNvPr id="2" name="">
             <a:extLst xmlns:a="http://schemas.openxmlformats.org/drawingml/2006/main">
               <a:ext uri="{FF2B5EF4-FFF2-40B4-BE49-F238E27FC236}">
-                <a16:creationId xmlns:a16="http://schemas.microsoft.com/office/drawing/2014/main" id="{3E8D8850-ADC4-4EF8-BC2B-B32B9C50FE3E}"/>
+                <a16:creationId xmlns:a16="http://schemas.microsoft.com/office/drawing/2014/main" id="{EEF163AB-8DB7-4700-AD27-42CE06AB7841}"/>
               </a:ext>
             </a:extLst>
           </p:cNvPr>
@@ -5159,7 +5159,7 @@
           <p:cNvPr id="3" name="">
             <a:extLst xmlns:a="http://schemas.openxmlformats.org/drawingml/2006/main">
               <a:ext uri="{FF2B5EF4-FFF2-40B4-BE49-F238E27FC236}">
-                <a16:creationId xmlns:a16="http://schemas.microsoft.com/office/drawing/2014/main" id="{5A97EC9E-C690-4666-AB27-E22BA7EFA4CC}"/>
+                <a16:creationId xmlns:a16="http://schemas.microsoft.com/office/drawing/2014/main" id="{56C5D3F4-BD39-4F88-A701-3316085DC7E2}"/>
               </a:ext>
             </a:extLst>
           </p:cNvPr>
@@ -5315,7 +5315,7 @@
           <p:cNvPr id="4" name="">
             <a:extLst xmlns:a="http://schemas.openxmlformats.org/drawingml/2006/main">
               <a:ext uri="{FF2B5EF4-FFF2-40B4-BE49-F238E27FC236}">
-                <a16:creationId xmlns:a16="http://schemas.microsoft.com/office/drawing/2014/main" id="{601D3179-64B9-4C98-BCBC-5D17BD8729A3}"/>
+                <a16:creationId xmlns:a16="http://schemas.microsoft.com/office/drawing/2014/main" id="{D95B3A81-1B7C-46A0-B21D-85437BBCBC76}"/>
               </a:ext>
             </a:extLst>
           </p:cNvPr>
@@ -5471,7 +5471,7 @@
           <p:cNvPr id="5" name="">
             <a:extLst xmlns:a="http://schemas.openxmlformats.org/drawingml/2006/main">
               <a:ext uri="{FF2B5EF4-FFF2-40B4-BE49-F238E27FC236}">
-                <a16:creationId xmlns:a16="http://schemas.microsoft.com/office/drawing/2014/main" id="{76F059BE-E187-4A2E-A93F-CEE21D2D21EE}"/>
+                <a16:creationId xmlns:a16="http://schemas.microsoft.com/office/drawing/2014/main" id="{498A027D-AFA2-4C5B-A901-DB9F55D2D897}"/>
               </a:ext>
             </a:extLst>
           </p:cNvPr>
@@ -5627,7 +5627,7 @@
           <p:cNvPr id="6" name="">
             <a:extLst xmlns:a="http://schemas.openxmlformats.org/drawingml/2006/main">
               <a:ext uri="{FF2B5EF4-FFF2-40B4-BE49-F238E27FC236}">
-                <a16:creationId xmlns:a16="http://schemas.microsoft.com/office/drawing/2014/main" id="{E88BBC6B-404D-4912-810C-730798EF189E}"/>
+                <a16:creationId xmlns:a16="http://schemas.microsoft.com/office/drawing/2014/main" id="{61AD3FD9-341D-4007-AE6B-F806E7678CE0}"/>
               </a:ext>
             </a:extLst>
           </p:cNvPr>
@@ -5783,7 +5783,7 @@
           <p:cNvPr id="7" name="">
             <a:extLst xmlns:a="http://schemas.openxmlformats.org/drawingml/2006/main">
               <a:ext uri="{FF2B5EF4-FFF2-40B4-BE49-F238E27FC236}">
-                <a16:creationId xmlns:a16="http://schemas.microsoft.com/office/drawing/2014/main" id="{1A589A04-FE3D-414F-960B-89B8FD9FBE61}"/>
+                <a16:creationId xmlns:a16="http://schemas.microsoft.com/office/drawing/2014/main" id="{2356A9BE-5BE2-4F89-A93E-6E1CC34F80D2}"/>
               </a:ext>
             </a:extLst>
           </p:cNvPr>
@@ -5937,7 +5937,7 @@
     </p:spTree>
     <p:extLst>
       <p:ext uri="{BB962C8B-B14F-4D97-AF65-F5344CB8AC3E}">
-        <p14:creationId xmlns:p14="http://schemas.microsoft.com/office/powerpoint/2010/main" val="1747146060"/>
+        <p14:creationId xmlns:p14="http://schemas.microsoft.com/office/powerpoint/2010/main" val="1016747519"/>
       </p:ext>
     </p:extLst>
   </p:cSld>
@@ -5968,7 +5968,7 @@
           <p:cNvPr id="5" name="">
             <a:extLst xmlns:a="http://schemas.openxmlformats.org/drawingml/2006/main">
               <a:ext uri="{FF2B5EF4-FFF2-40B4-BE49-F238E27FC236}">
-                <a16:creationId xmlns:a16="http://schemas.microsoft.com/office/drawing/2014/main" id="{684F01D3-37F0-4B35-B845-D2356670FFCC}"/>
+                <a16:creationId xmlns:a16="http://schemas.microsoft.com/office/drawing/2014/main" id="{F302A19D-FF69-4366-8E48-21B1EA4C83D8}"/>
               </a:ext>
             </a:extLst>
           </p:cNvPr>
@@ -6124,7 +6124,7 @@
           <p:cNvPr id="2" name="">
             <a:extLst xmlns:a="http://schemas.openxmlformats.org/drawingml/2006/main">
               <a:ext uri="{FF2B5EF4-FFF2-40B4-BE49-F238E27FC236}">
-                <a16:creationId xmlns:a16="http://schemas.microsoft.com/office/drawing/2014/main" id="{E6559506-9058-481D-9C76-268980B43A26}"/>
+                <a16:creationId xmlns:a16="http://schemas.microsoft.com/office/drawing/2014/main" id="{32566864-7212-4992-A02F-5D8FE67EC730}"/>
               </a:ext>
             </a:extLst>
           </p:cNvPr>
@@ -6280,7 +6280,7 @@
           <p:cNvPr id="3" name="">
             <a:extLst xmlns:a="http://schemas.openxmlformats.org/drawingml/2006/main">
               <a:ext uri="{FF2B5EF4-FFF2-40B4-BE49-F238E27FC236}">
-                <a16:creationId xmlns:a16="http://schemas.microsoft.com/office/drawing/2014/main" id="{B5C488D8-0748-4D24-8C80-6D05C6BEACF7}"/>
+                <a16:creationId xmlns:a16="http://schemas.microsoft.com/office/drawing/2014/main" id="{90012184-0F94-44CC-86DA-81D8915AFE0E}"/>
               </a:ext>
             </a:extLst>
           </p:cNvPr>
@@ -6791,7 +6791,7 @@
           <p:cNvPr id="4" name="">
             <a:extLst xmlns:a="http://schemas.openxmlformats.org/drawingml/2006/main">
               <a:ext uri="{FF2B5EF4-FFF2-40B4-BE49-F238E27FC236}">
-                <a16:creationId xmlns:a16="http://schemas.microsoft.com/office/drawing/2014/main" id="{D59E1D9B-DF56-4A6B-A245-52309D45F361}"/>
+                <a16:creationId xmlns:a16="http://schemas.microsoft.com/office/drawing/2014/main" id="{57EE37AE-BD44-44CA-B152-3288DC17C35D}"/>
               </a:ext>
             </a:extLst>
           </p:cNvPr>
@@ -6945,7 +6945,7 @@
     </p:spTree>
     <p:extLst>
       <p:ext uri="{BB962C8B-B14F-4D97-AF65-F5344CB8AC3E}">
-        <p14:creationId xmlns:p14="http://schemas.microsoft.com/office/powerpoint/2010/main" val="708038326"/>
+        <p14:creationId xmlns:p14="http://schemas.microsoft.com/office/powerpoint/2010/main" val="1874458300"/>
       </p:ext>
     </p:extLst>
   </p:cSld>
@@ -6976,7 +6976,7 @@
           <p:cNvPr id="12" name="">
             <a:extLst xmlns:a="http://schemas.openxmlformats.org/drawingml/2006/main">
               <a:ext uri="{FF2B5EF4-FFF2-40B4-BE49-F238E27FC236}">
-                <a16:creationId xmlns:a16="http://schemas.microsoft.com/office/drawing/2014/main" id="{93A36B68-F206-4F8C-B383-8785BBA60D8F}"/>
+                <a16:creationId xmlns:a16="http://schemas.microsoft.com/office/drawing/2014/main" id="{94CD7AC8-7653-40E2-A0F8-20CF42820406}"/>
               </a:ext>
             </a:extLst>
           </p:cNvPr>
@@ -7132,7 +7132,7 @@
           <p:cNvPr id="2" name="">
             <a:extLst xmlns:a="http://schemas.openxmlformats.org/drawingml/2006/main">
               <a:ext uri="{FF2B5EF4-FFF2-40B4-BE49-F238E27FC236}">
-                <a16:creationId xmlns:a16="http://schemas.microsoft.com/office/drawing/2014/main" id="{FD8267AC-DD93-433B-B486-5427DDAD4867}"/>
+                <a16:creationId xmlns:a16="http://schemas.microsoft.com/office/drawing/2014/main" id="{3B159E8D-83F2-43FA-A979-FB0F20AB7AC9}"/>
               </a:ext>
             </a:extLst>
           </p:cNvPr>
@@ -7288,7 +7288,7 @@
           <p:cNvPr id="3" name="">
             <a:extLst xmlns:a="http://schemas.openxmlformats.org/drawingml/2006/main">
               <a:ext uri="{FF2B5EF4-FFF2-40B4-BE49-F238E27FC236}">
-                <a16:creationId xmlns:a16="http://schemas.microsoft.com/office/drawing/2014/main" id="{CE339915-0BBA-4BC6-A632-1EC47668CC09}"/>
+                <a16:creationId xmlns:a16="http://schemas.microsoft.com/office/drawing/2014/main" id="{5DCFCFF6-F9A0-47E4-BD1F-EECCCC6735D2}"/>
               </a:ext>
             </a:extLst>
           </p:cNvPr>
@@ -7444,7 +7444,7 @@
           <p:cNvPr id="4" name="">
             <a:extLst xmlns:a="http://schemas.openxmlformats.org/drawingml/2006/main">
               <a:ext uri="{FF2B5EF4-FFF2-40B4-BE49-F238E27FC236}">
-                <a16:creationId xmlns:a16="http://schemas.microsoft.com/office/drawing/2014/main" id="{9A03217E-1AD9-4177-B14D-E2899B1BA61F}"/>
+                <a16:creationId xmlns:a16="http://schemas.microsoft.com/office/drawing/2014/main" id="{07D656B4-473C-4CCA-B989-E788F3C825DE}"/>
               </a:ext>
             </a:extLst>
           </p:cNvPr>
@@ -7600,7 +7600,7 @@
           <p:cNvPr id="5" name="">
             <a:extLst xmlns:a="http://schemas.openxmlformats.org/drawingml/2006/main">
               <a:ext uri="{FF2B5EF4-FFF2-40B4-BE49-F238E27FC236}">
-                <a16:creationId xmlns:a16="http://schemas.microsoft.com/office/drawing/2014/main" id="{BF56F1EC-B518-4A73-A532-2F6A9F692B2B}"/>
+                <a16:creationId xmlns:a16="http://schemas.microsoft.com/office/drawing/2014/main" id="{91C32DCE-55A8-495D-91A5-BD6610394DBB}"/>
               </a:ext>
             </a:extLst>
           </p:cNvPr>
@@ -7756,7 +7756,7 @@
           <p:cNvPr id="6" name="">
             <a:extLst xmlns:a="http://schemas.openxmlformats.org/drawingml/2006/main">
               <a:ext uri="{FF2B5EF4-FFF2-40B4-BE49-F238E27FC236}">
-                <a16:creationId xmlns:a16="http://schemas.microsoft.com/office/drawing/2014/main" id="{0D007DDD-3F16-4384-A641-A94DB47431B8}"/>
+                <a16:creationId xmlns:a16="http://schemas.microsoft.com/office/drawing/2014/main" id="{62258A65-CCEF-4B48-9B21-88256A3585D5}"/>
               </a:ext>
             </a:extLst>
           </p:cNvPr>
@@ -7912,7 +7912,7 @@
           <p:cNvPr id="7" name="">
             <a:extLst xmlns:a="http://schemas.openxmlformats.org/drawingml/2006/main">
               <a:ext uri="{FF2B5EF4-FFF2-40B4-BE49-F238E27FC236}">
-                <a16:creationId xmlns:a16="http://schemas.microsoft.com/office/drawing/2014/main" id="{92D2A72A-5045-47B6-A06A-8C6A16E4765A}"/>
+                <a16:creationId xmlns:a16="http://schemas.microsoft.com/office/drawing/2014/main" id="{F5882C74-2982-4B8D-AEE5-7BDD44F63F5E}"/>
               </a:ext>
             </a:extLst>
           </p:cNvPr>
@@ -8068,7 +8068,7 @@
           <p:cNvPr id="8" name="">
             <a:extLst xmlns:a="http://schemas.openxmlformats.org/drawingml/2006/main">
               <a:ext uri="{FF2B5EF4-FFF2-40B4-BE49-F238E27FC236}">
-                <a16:creationId xmlns:a16="http://schemas.microsoft.com/office/drawing/2014/main" id="{7A4BB550-63EA-4EEC-9053-80D688F97962}"/>
+                <a16:creationId xmlns:a16="http://schemas.microsoft.com/office/drawing/2014/main" id="{0AD3A554-7EB4-4886-9AFB-4DCEDA079067}"/>
               </a:ext>
             </a:extLst>
           </p:cNvPr>
@@ -8224,7 +8224,7 @@
           <p:cNvPr id="9" name="">
             <a:extLst xmlns:a="http://schemas.openxmlformats.org/drawingml/2006/main">
               <a:ext uri="{FF2B5EF4-FFF2-40B4-BE49-F238E27FC236}">
-                <a16:creationId xmlns:a16="http://schemas.microsoft.com/office/drawing/2014/main" id="{7473A79E-D370-4A5A-8780-2FD5D8B7EF90}"/>
+                <a16:creationId xmlns:a16="http://schemas.microsoft.com/office/drawing/2014/main" id="{90748865-15C1-4841-B8F8-C392F87FA4FD}"/>
               </a:ext>
             </a:extLst>
           </p:cNvPr>
@@ -8380,7 +8380,7 @@
           <p:cNvPr id="10" name="">
             <a:extLst xmlns:a="http://schemas.openxmlformats.org/drawingml/2006/main">
               <a:ext uri="{FF2B5EF4-FFF2-40B4-BE49-F238E27FC236}">
-                <a16:creationId xmlns:a16="http://schemas.microsoft.com/office/drawing/2014/main" id="{2F1B1440-EB4C-4225-ABC2-D4F7E2690F75}"/>
+                <a16:creationId xmlns:a16="http://schemas.microsoft.com/office/drawing/2014/main" id="{63CFF05C-B570-4336-9E60-A871C40FE45F}"/>
               </a:ext>
             </a:extLst>
           </p:cNvPr>
@@ -8536,7 +8536,7 @@
           <p:cNvPr id="11" name="">
             <a:extLst xmlns:a="http://schemas.openxmlformats.org/drawingml/2006/main">
               <a:ext uri="{FF2B5EF4-FFF2-40B4-BE49-F238E27FC236}">
-                <a16:creationId xmlns:a16="http://schemas.microsoft.com/office/drawing/2014/main" id="{2F87E45F-58C4-43E2-95D9-FA6DE75DB6E9}"/>
+                <a16:creationId xmlns:a16="http://schemas.microsoft.com/office/drawing/2014/main" id="{9B523E1F-9F98-4C15-BCC6-2978C1FE308D}"/>
               </a:ext>
             </a:extLst>
           </p:cNvPr>
@@ -8690,7 +8690,7 @@
     </p:spTree>
     <p:extLst>
       <p:ext uri="{BB962C8B-B14F-4D97-AF65-F5344CB8AC3E}">
-        <p14:creationId xmlns:p14="http://schemas.microsoft.com/office/powerpoint/2010/main" val="2118909559"/>
+        <p14:creationId xmlns:p14="http://schemas.microsoft.com/office/powerpoint/2010/main" val="192823472"/>
       </p:ext>
     </p:extLst>
   </p:cSld>
@@ -8721,7 +8721,7 @@
           <p:cNvPr id="17" name="">
             <a:extLst xmlns:a="http://schemas.openxmlformats.org/drawingml/2006/main">
               <a:ext uri="{FF2B5EF4-FFF2-40B4-BE49-F238E27FC236}">
-                <a16:creationId xmlns:a16="http://schemas.microsoft.com/office/drawing/2014/main" id="{1E294E41-98FE-44D4-B873-E2A6868467D1}"/>
+                <a16:creationId xmlns:a16="http://schemas.microsoft.com/office/drawing/2014/main" id="{025B7F2E-D167-4AF9-8180-5BDE73E1AF45}"/>
               </a:ext>
             </a:extLst>
           </p:cNvPr>
@@ -8877,7 +8877,7 @@
           <p:cNvPr id="2" name="">
             <a:extLst xmlns:a="http://schemas.openxmlformats.org/drawingml/2006/main">
               <a:ext uri="{FF2B5EF4-FFF2-40B4-BE49-F238E27FC236}">
-                <a16:creationId xmlns:a16="http://schemas.microsoft.com/office/drawing/2014/main" id="{BFE16AD4-85CE-4217-B765-32B43CD16A9E}"/>
+                <a16:creationId xmlns:a16="http://schemas.microsoft.com/office/drawing/2014/main" id="{236C3B3A-8738-47CA-B245-22B0FD47D4AB}"/>
               </a:ext>
             </a:extLst>
           </p:cNvPr>
@@ -9033,7 +9033,7 @@
           <p:cNvPr id="3" name="">
             <a:extLst xmlns:a="http://schemas.openxmlformats.org/drawingml/2006/main">
               <a:ext uri="{FF2B5EF4-FFF2-40B4-BE49-F238E27FC236}">
-                <a16:creationId xmlns:a16="http://schemas.microsoft.com/office/drawing/2014/main" id="{A14C43E0-53CA-426C-BE66-B85C7E559E20}"/>
+                <a16:creationId xmlns:a16="http://schemas.microsoft.com/office/drawing/2014/main" id="{C2174BBC-48A1-490C-A12E-8F740194AD62}"/>
               </a:ext>
             </a:extLst>
           </p:cNvPr>
@@ -9189,7 +9189,7 @@
           <p:cNvPr id="4" name="">
             <a:extLst xmlns:a="http://schemas.openxmlformats.org/drawingml/2006/main">
               <a:ext uri="{FF2B5EF4-FFF2-40B4-BE49-F238E27FC236}">
-                <a16:creationId xmlns:a16="http://schemas.microsoft.com/office/drawing/2014/main" id="{81A71244-06B9-4869-9BA7-7648A13BF14C}"/>
+                <a16:creationId xmlns:a16="http://schemas.microsoft.com/office/drawing/2014/main" id="{46689970-83B7-44A7-86FF-893D1E2DCA17}"/>
               </a:ext>
             </a:extLst>
           </p:cNvPr>
@@ -9199,7 +9199,7 @@
           <p:nvPr/>
         </p:nvPicPr>
         <p:blipFill>
-          <a:blip xmlns:r="http://schemas.openxmlformats.org/officeDocument/2006/relationships" xmlns:a="http://schemas.openxmlformats.org/drawingml/2006/main" r:embed="R7c28da1504c046cb"/>
+          <a:blip xmlns:r="http://schemas.openxmlformats.org/officeDocument/2006/relationships" xmlns:a="http://schemas.openxmlformats.org/drawingml/2006/main" r:embed="R82617658af2d44bf"/>
           <a:stretch xmlns:a="http://schemas.openxmlformats.org/drawingml/2006/main"/>
         </p:blipFill>
         <p:spPr>
@@ -9217,7 +9217,7 @@
           <p:cNvPr id="5" name="">
             <a:extLst xmlns:a="http://schemas.openxmlformats.org/drawingml/2006/main">
               <a:ext uri="{FF2B5EF4-FFF2-40B4-BE49-F238E27FC236}">
-                <a16:creationId xmlns:a16="http://schemas.microsoft.com/office/drawing/2014/main" id="{4F308267-AE42-46AB-A045-98771148983A}"/>
+                <a16:creationId xmlns:a16="http://schemas.microsoft.com/office/drawing/2014/main" id="{6AE5AC36-5B5F-4D9B-86A5-3E05336A83CE}"/>
               </a:ext>
             </a:extLst>
           </p:cNvPr>
@@ -9373,7 +9373,7 @@
           <p:cNvPr id="6" name="">
             <a:extLst xmlns:a="http://schemas.openxmlformats.org/drawingml/2006/main">
               <a:ext uri="{FF2B5EF4-FFF2-40B4-BE49-F238E27FC236}">
-                <a16:creationId xmlns:a16="http://schemas.microsoft.com/office/drawing/2014/main" id="{A9D77C70-DAC4-4E21-88F9-8BC27C5C765D}"/>
+                <a16:creationId xmlns:a16="http://schemas.microsoft.com/office/drawing/2014/main" id="{D4CA62DC-8F9D-46EB-B578-3D79D5477DC4}"/>
               </a:ext>
             </a:extLst>
           </p:cNvPr>
@@ -9383,7 +9383,7 @@
           <p:nvPr/>
         </p:nvPicPr>
         <p:blipFill>
-          <a:blip xmlns:r="http://schemas.openxmlformats.org/officeDocument/2006/relationships" xmlns:a="http://schemas.openxmlformats.org/drawingml/2006/main" r:embed="Rbd49b1408f974be3"/>
+          <a:blip xmlns:r="http://schemas.openxmlformats.org/officeDocument/2006/relationships" xmlns:a="http://schemas.openxmlformats.org/drawingml/2006/main" r:embed="R7d0edc8effb146d1"/>
           <a:stretch xmlns:a="http://schemas.openxmlformats.org/drawingml/2006/main"/>
         </p:blipFill>
         <p:spPr>
@@ -9401,7 +9401,7 @@
           <p:cNvPr id="7" name="">
             <a:extLst xmlns:a="http://schemas.openxmlformats.org/drawingml/2006/main">
               <a:ext uri="{FF2B5EF4-FFF2-40B4-BE49-F238E27FC236}">
-                <a16:creationId xmlns:a16="http://schemas.microsoft.com/office/drawing/2014/main" id="{E68385D3-1B81-47B2-8C01-0E90AE5E14C4}"/>
+                <a16:creationId xmlns:a16="http://schemas.microsoft.com/office/drawing/2014/main" id="{75553964-F341-4A0A-BA0B-6435D4B6B801}"/>
               </a:ext>
             </a:extLst>
           </p:cNvPr>
@@ -9557,7 +9557,7 @@
           <p:cNvPr id="8" name="">
             <a:extLst xmlns:a="http://schemas.openxmlformats.org/drawingml/2006/main">
               <a:ext uri="{FF2B5EF4-FFF2-40B4-BE49-F238E27FC236}">
-                <a16:creationId xmlns:a16="http://schemas.microsoft.com/office/drawing/2014/main" id="{5189DE23-E65D-40ED-B609-0C80FA763C1A}"/>
+                <a16:creationId xmlns:a16="http://schemas.microsoft.com/office/drawing/2014/main" id="{9BA2416E-99A2-4231-99DE-A854EFB959B8}"/>
               </a:ext>
             </a:extLst>
           </p:cNvPr>
@@ -9567,7 +9567,7 @@
           <p:nvPr/>
         </p:nvPicPr>
         <p:blipFill>
-          <a:blip xmlns:r="http://schemas.openxmlformats.org/officeDocument/2006/relationships" xmlns:a="http://schemas.openxmlformats.org/drawingml/2006/main" r:embed="R67d2bea65bca4dd7"/>
+          <a:blip xmlns:r="http://schemas.openxmlformats.org/officeDocument/2006/relationships" xmlns:a="http://schemas.openxmlformats.org/drawingml/2006/main" r:embed="Rd41f662385914a01"/>
           <a:stretch xmlns:a="http://schemas.openxmlformats.org/drawingml/2006/main"/>
         </p:blipFill>
         <p:spPr>
@@ -9585,7 +9585,7 @@
           <p:cNvPr id="9" name="">
             <a:extLst xmlns:a="http://schemas.openxmlformats.org/drawingml/2006/main">
               <a:ext uri="{FF2B5EF4-FFF2-40B4-BE49-F238E27FC236}">
-                <a16:creationId xmlns:a16="http://schemas.microsoft.com/office/drawing/2014/main" id="{95E7A296-5E84-428C-A51F-A20D1949BEED}"/>
+                <a16:creationId xmlns:a16="http://schemas.microsoft.com/office/drawing/2014/main" id="{290A8F21-9B4D-4489-A367-8C84DFE66FB5}"/>
               </a:ext>
             </a:extLst>
           </p:cNvPr>
@@ -9741,7 +9741,7 @@
           <p:cNvPr id="10" name="">
             <a:extLst xmlns:a="http://schemas.openxmlformats.org/drawingml/2006/main">
               <a:ext uri="{FF2B5EF4-FFF2-40B4-BE49-F238E27FC236}">
-                <a16:creationId xmlns:a16="http://schemas.microsoft.com/office/drawing/2014/main" id="{DC038047-9305-4A4C-990E-302818527AF5}"/>
+                <a16:creationId xmlns:a16="http://schemas.microsoft.com/office/drawing/2014/main" id="{A63D9CAF-DFDE-4153-876C-2630CB3B765C}"/>
               </a:ext>
             </a:extLst>
           </p:cNvPr>
@@ -9751,7 +9751,7 @@
           <p:nvPr/>
         </p:nvPicPr>
         <p:blipFill>
-          <a:blip xmlns:r="http://schemas.openxmlformats.org/officeDocument/2006/relationships" xmlns:a="http://schemas.openxmlformats.org/drawingml/2006/main" r:embed="R96185a607f13417c"/>
+          <a:blip xmlns:r="http://schemas.openxmlformats.org/officeDocument/2006/relationships" xmlns:a="http://schemas.openxmlformats.org/drawingml/2006/main" r:embed="Reb2e9f7df2f043ed"/>
           <a:stretch xmlns:a="http://schemas.openxmlformats.org/drawingml/2006/main"/>
         </p:blipFill>
         <p:spPr>
@@ -9769,7 +9769,7 @@
           <p:cNvPr id="11" name="">
             <a:extLst xmlns:a="http://schemas.openxmlformats.org/drawingml/2006/main">
               <a:ext uri="{FF2B5EF4-FFF2-40B4-BE49-F238E27FC236}">
-                <a16:creationId xmlns:a16="http://schemas.microsoft.com/office/drawing/2014/main" id="{6C24CD7B-F6AD-4A57-87E3-91114CB21554}"/>
+                <a16:creationId xmlns:a16="http://schemas.microsoft.com/office/drawing/2014/main" id="{15181D4D-D295-4FE3-9890-AD25B0B7B5B8}"/>
               </a:ext>
             </a:extLst>
           </p:cNvPr>
@@ -9925,7 +9925,7 @@
           <p:cNvPr id="12" name="">
             <a:extLst xmlns:a="http://schemas.openxmlformats.org/drawingml/2006/main">
               <a:ext uri="{FF2B5EF4-FFF2-40B4-BE49-F238E27FC236}">
-                <a16:creationId xmlns:a16="http://schemas.microsoft.com/office/drawing/2014/main" id="{3292183A-A5C6-44CA-80F5-20BE898507F7}"/>
+                <a16:creationId xmlns:a16="http://schemas.microsoft.com/office/drawing/2014/main" id="{47049685-533E-4AA3-B28E-352588D4E62D}"/>
               </a:ext>
             </a:extLst>
           </p:cNvPr>
@@ -9935,7 +9935,7 @@
           <p:nvPr/>
         </p:nvPicPr>
         <p:blipFill>
-          <a:blip xmlns:r="http://schemas.openxmlformats.org/officeDocument/2006/relationships" xmlns:a="http://schemas.openxmlformats.org/drawingml/2006/main" r:embed="R4c533ad665a5426a"/>
+          <a:blip xmlns:r="http://schemas.openxmlformats.org/officeDocument/2006/relationships" xmlns:a="http://schemas.openxmlformats.org/drawingml/2006/main" r:embed="Red316de4881349e3"/>
           <a:stretch xmlns:a="http://schemas.openxmlformats.org/drawingml/2006/main"/>
         </p:blipFill>
         <p:spPr>
@@ -9953,7 +9953,7 @@
           <p:cNvPr id="13" name="">
             <a:extLst xmlns:a="http://schemas.openxmlformats.org/drawingml/2006/main">
               <a:ext uri="{FF2B5EF4-FFF2-40B4-BE49-F238E27FC236}">
-                <a16:creationId xmlns:a16="http://schemas.microsoft.com/office/drawing/2014/main" id="{B197E903-904D-476C-A116-16C0865CB953}"/>
+                <a16:creationId xmlns:a16="http://schemas.microsoft.com/office/drawing/2014/main" id="{CCDAAE3E-0347-45FB-ADE3-28D0BA60F770}"/>
               </a:ext>
             </a:extLst>
           </p:cNvPr>
@@ -10109,7 +10109,7 @@
           <p:cNvPr id="14" name="">
             <a:extLst xmlns:a="http://schemas.openxmlformats.org/drawingml/2006/main">
               <a:ext uri="{FF2B5EF4-FFF2-40B4-BE49-F238E27FC236}">
-                <a16:creationId xmlns:a16="http://schemas.microsoft.com/office/drawing/2014/main" id="{DAA7F9F6-3AB2-401D-B6C3-FAE89E99CA57}"/>
+                <a16:creationId xmlns:a16="http://schemas.microsoft.com/office/drawing/2014/main" id="{CB79218A-A93F-43AC-A052-996E21119FF7}"/>
               </a:ext>
             </a:extLst>
           </p:cNvPr>
@@ -10119,7 +10119,7 @@
           <p:nvPr/>
         </p:nvPicPr>
         <p:blipFill>
-          <a:blip xmlns:r="http://schemas.openxmlformats.org/officeDocument/2006/relationships" xmlns:a="http://schemas.openxmlformats.org/drawingml/2006/main" r:embed="R4eb4b8584be74181"/>
+          <a:blip xmlns:r="http://schemas.openxmlformats.org/officeDocument/2006/relationships" xmlns:a="http://schemas.openxmlformats.org/drawingml/2006/main" r:embed="R0f86780f17114336"/>
           <a:stretch xmlns:a="http://schemas.openxmlformats.org/drawingml/2006/main"/>
         </p:blipFill>
         <p:spPr>
@@ -10137,7 +10137,7 @@
           <p:cNvPr id="15" name="">
             <a:extLst xmlns:a="http://schemas.openxmlformats.org/drawingml/2006/main">
               <a:ext uri="{FF2B5EF4-FFF2-40B4-BE49-F238E27FC236}">
-                <a16:creationId xmlns:a16="http://schemas.microsoft.com/office/drawing/2014/main" id="{B8F76923-6291-4621-8A7B-CAC86D1984C2}"/>
+                <a16:creationId xmlns:a16="http://schemas.microsoft.com/office/drawing/2014/main" id="{62F50A8F-9D1A-444A-977C-3A148D3D57AF}"/>
               </a:ext>
             </a:extLst>
           </p:cNvPr>
@@ -10293,7 +10293,7 @@
           <p:cNvPr id="16" name="">
             <a:extLst xmlns:a="http://schemas.openxmlformats.org/drawingml/2006/main">
               <a:ext uri="{FF2B5EF4-FFF2-40B4-BE49-F238E27FC236}">
-                <a16:creationId xmlns:a16="http://schemas.microsoft.com/office/drawing/2014/main" id="{2440F831-95D1-4DC9-9928-61D5BBBF8C8B}"/>
+                <a16:creationId xmlns:a16="http://schemas.microsoft.com/office/drawing/2014/main" id="{BC1FE7AD-0BCD-43A2-AFCA-A0EFBEC8BECD}"/>
               </a:ext>
             </a:extLst>
           </p:cNvPr>
@@ -10447,7 +10447,7 @@
     </p:spTree>
     <p:extLst>
       <p:ext uri="{BB962C8B-B14F-4D97-AF65-F5344CB8AC3E}">
-        <p14:creationId xmlns:p14="http://schemas.microsoft.com/office/powerpoint/2010/main" val="1984792387"/>
+        <p14:creationId xmlns:p14="http://schemas.microsoft.com/office/powerpoint/2010/main" val="664513414"/>
       </p:ext>
     </p:extLst>
   </p:cSld>
@@ -10478,7 +10478,7 @@
           <p:cNvPr id="9" name="">
             <a:extLst xmlns:a="http://schemas.openxmlformats.org/drawingml/2006/main">
               <a:ext uri="{FF2B5EF4-FFF2-40B4-BE49-F238E27FC236}">
-                <a16:creationId xmlns:a16="http://schemas.microsoft.com/office/drawing/2014/main" id="{0E2EF097-F4D9-4D16-AA51-0741CADCD735}"/>
+                <a16:creationId xmlns:a16="http://schemas.microsoft.com/office/drawing/2014/main" id="{033FC660-4905-4E6A-8B06-E2CEA2669902}"/>
               </a:ext>
             </a:extLst>
           </p:cNvPr>
@@ -10634,7 +10634,7 @@
           <p:cNvPr id="2" name="">
             <a:extLst xmlns:a="http://schemas.openxmlformats.org/drawingml/2006/main">
               <a:ext uri="{FF2B5EF4-FFF2-40B4-BE49-F238E27FC236}">
-                <a16:creationId xmlns:a16="http://schemas.microsoft.com/office/drawing/2014/main" id="{C274BD20-91AE-4A10-BB3C-DC9F1B9A2E69}"/>
+                <a16:creationId xmlns:a16="http://schemas.microsoft.com/office/drawing/2014/main" id="{A2FBA98B-201F-4D41-BACA-95ECDA8C0EAF}"/>
               </a:ext>
             </a:extLst>
           </p:cNvPr>
@@ -10790,7 +10790,7 @@
           <p:cNvPr id="3" name="">
             <a:extLst xmlns:a="http://schemas.openxmlformats.org/drawingml/2006/main">
               <a:ext uri="{FF2B5EF4-FFF2-40B4-BE49-F238E27FC236}">
-                <a16:creationId xmlns:a16="http://schemas.microsoft.com/office/drawing/2014/main" id="{9D7B577D-67EB-4CF4-97EC-07086E9EE136}"/>
+                <a16:creationId xmlns:a16="http://schemas.microsoft.com/office/drawing/2014/main" id="{36DA9DFF-BA13-4CF5-A74E-73C95AFFC036}"/>
               </a:ext>
             </a:extLst>
           </p:cNvPr>
@@ -10946,7 +10946,7 @@
           <p:cNvPr id="4" name="">
             <a:extLst xmlns:a="http://schemas.openxmlformats.org/drawingml/2006/main">
               <a:ext uri="{FF2B5EF4-FFF2-40B4-BE49-F238E27FC236}">
-                <a16:creationId xmlns:a16="http://schemas.microsoft.com/office/drawing/2014/main" id="{AA43132B-5664-45AD-B29F-68706996E967}"/>
+                <a16:creationId xmlns:a16="http://schemas.microsoft.com/office/drawing/2014/main" id="{54C1CE09-68B0-4C06-94D8-2C04F418811C}"/>
               </a:ext>
             </a:extLst>
           </p:cNvPr>
@@ -11102,7 +11102,7 @@
           <p:cNvPr id="5" name="">
             <a:extLst xmlns:a="http://schemas.openxmlformats.org/drawingml/2006/main">
               <a:ext uri="{FF2B5EF4-FFF2-40B4-BE49-F238E27FC236}">
-                <a16:creationId xmlns:a16="http://schemas.microsoft.com/office/drawing/2014/main" id="{9D0BD2BA-7F80-46B5-B758-C7C8426A2BB8}"/>
+                <a16:creationId xmlns:a16="http://schemas.microsoft.com/office/drawing/2014/main" id="{51CC8162-C026-4DF6-B7B0-333089A1CDAB}"/>
               </a:ext>
             </a:extLst>
           </p:cNvPr>
@@ -11258,7 +11258,7 @@
           <p:cNvPr id="6" name="">
             <a:extLst xmlns:a="http://schemas.openxmlformats.org/drawingml/2006/main">
               <a:ext uri="{FF2B5EF4-FFF2-40B4-BE49-F238E27FC236}">
-                <a16:creationId xmlns:a16="http://schemas.microsoft.com/office/drawing/2014/main" id="{4F83D665-C628-446C-B7C3-E8EEFC8587B5}"/>
+                <a16:creationId xmlns:a16="http://schemas.microsoft.com/office/drawing/2014/main" id="{3C119D8C-B41D-4321-BDF6-EC3B3A7143BA}"/>
               </a:ext>
             </a:extLst>
           </p:cNvPr>
@@ -11414,7 +11414,7 @@
           <p:cNvPr id="7" name="">
             <a:extLst xmlns:a="http://schemas.openxmlformats.org/drawingml/2006/main">
               <a:ext uri="{FF2B5EF4-FFF2-40B4-BE49-F238E27FC236}">
-                <a16:creationId xmlns:a16="http://schemas.microsoft.com/office/drawing/2014/main" id="{FB132714-EB38-4FF1-A9CE-FC2DF41615D6}"/>
+                <a16:creationId xmlns:a16="http://schemas.microsoft.com/office/drawing/2014/main" id="{F283BF8E-76A7-49AE-98D7-B0344A27C6D8}"/>
               </a:ext>
             </a:extLst>
           </p:cNvPr>
@@ -11570,7 +11570,7 @@
           <p:cNvPr id="8" name="">
             <a:extLst xmlns:a="http://schemas.openxmlformats.org/drawingml/2006/main">
               <a:ext uri="{FF2B5EF4-FFF2-40B4-BE49-F238E27FC236}">
-                <a16:creationId xmlns:a16="http://schemas.microsoft.com/office/drawing/2014/main" id="{B6AEBD37-3951-4006-A9FE-DB870F9C359C}"/>
+                <a16:creationId xmlns:a16="http://schemas.microsoft.com/office/drawing/2014/main" id="{D10214E0-BA18-47B4-BC43-915C123D14A9}"/>
               </a:ext>
             </a:extLst>
           </p:cNvPr>
@@ -11724,7 +11724,7 @@
     </p:spTree>
     <p:extLst>
       <p:ext uri="{BB962C8B-B14F-4D97-AF65-F5344CB8AC3E}">
-        <p14:creationId xmlns:p14="http://schemas.microsoft.com/office/powerpoint/2010/main" val="928816254"/>
+        <p14:creationId xmlns:p14="http://schemas.microsoft.com/office/powerpoint/2010/main" val="1481154280"/>
       </p:ext>
     </p:extLst>
   </p:cSld>
@@ -11755,7 +11755,7 @@
           <p:cNvPr id="7" name="">
             <a:extLst xmlns:a="http://schemas.openxmlformats.org/drawingml/2006/main">
               <a:ext uri="{FF2B5EF4-FFF2-40B4-BE49-F238E27FC236}">
-                <a16:creationId xmlns:a16="http://schemas.microsoft.com/office/drawing/2014/main" id="{7473FFDF-7585-47BD-966E-D9E979FC273F}"/>
+                <a16:creationId xmlns:a16="http://schemas.microsoft.com/office/drawing/2014/main" id="{3B05023F-1112-427D-98A1-860BCCCCDAC3}"/>
               </a:ext>
             </a:extLst>
           </p:cNvPr>
@@ -11911,7 +11911,7 @@
           <p:cNvPr id="2" name="">
             <a:extLst xmlns:a="http://schemas.openxmlformats.org/drawingml/2006/main">
               <a:ext uri="{FF2B5EF4-FFF2-40B4-BE49-F238E27FC236}">
-                <a16:creationId xmlns:a16="http://schemas.microsoft.com/office/drawing/2014/main" id="{A5CFF613-B3BF-4FD0-AB3A-E3DC65D75D71}"/>
+                <a16:creationId xmlns:a16="http://schemas.microsoft.com/office/drawing/2014/main" id="{D4459087-AE5B-4CED-A001-394E9576DFFA}"/>
               </a:ext>
             </a:extLst>
           </p:cNvPr>
@@ -12067,7 +12067,7 @@
           <p:cNvPr id="3" name="">
             <a:extLst xmlns:a="http://schemas.openxmlformats.org/drawingml/2006/main">
               <a:ext uri="{FF2B5EF4-FFF2-40B4-BE49-F238E27FC236}">
-                <a16:creationId xmlns:a16="http://schemas.microsoft.com/office/drawing/2014/main" id="{2F2F296D-D104-4DDA-805A-B36820345E3F}"/>
+                <a16:creationId xmlns:a16="http://schemas.microsoft.com/office/drawing/2014/main" id="{DFF11359-2EBC-4F8F-80C8-B4DE952574B7}"/>
               </a:ext>
             </a:extLst>
           </p:cNvPr>
@@ -12223,7 +12223,7 @@
           <p:cNvPr id="4" name="">
             <a:extLst xmlns:a="http://schemas.openxmlformats.org/drawingml/2006/main">
               <a:ext uri="{FF2B5EF4-FFF2-40B4-BE49-F238E27FC236}">
-                <a16:creationId xmlns:a16="http://schemas.microsoft.com/office/drawing/2014/main" id="{EEA84BFB-032D-4DD2-B12A-9C48D7C81D34}"/>
+                <a16:creationId xmlns:a16="http://schemas.microsoft.com/office/drawing/2014/main" id="{21FCE899-2872-4638-9E78-26F893C99B73}"/>
               </a:ext>
             </a:extLst>
           </p:cNvPr>
@@ -12379,7 +12379,7 @@
           <p:cNvPr id="5" name="">
             <a:extLst xmlns:a="http://schemas.openxmlformats.org/drawingml/2006/main">
               <a:ext uri="{FF2B5EF4-FFF2-40B4-BE49-F238E27FC236}">
-                <a16:creationId xmlns:a16="http://schemas.microsoft.com/office/drawing/2014/main" id="{7E4248F5-C8FC-43CC-95FC-A75C2F1681DE}"/>
+                <a16:creationId xmlns:a16="http://schemas.microsoft.com/office/drawing/2014/main" id="{55C20000-5FE1-498B-AF13-28573117FE7A}"/>
               </a:ext>
             </a:extLst>
           </p:cNvPr>
@@ -12535,7 +12535,7 @@
           <p:cNvPr id="6" name="">
             <a:extLst xmlns:a="http://schemas.openxmlformats.org/drawingml/2006/main">
               <a:ext uri="{FF2B5EF4-FFF2-40B4-BE49-F238E27FC236}">
-                <a16:creationId xmlns:a16="http://schemas.microsoft.com/office/drawing/2014/main" id="{10187989-14BF-4AE4-8380-FA0F5CF9104B}"/>
+                <a16:creationId xmlns:a16="http://schemas.microsoft.com/office/drawing/2014/main" id="{C607755D-637B-4CDE-B6D0-284EE2F2E984}"/>
               </a:ext>
             </a:extLst>
           </p:cNvPr>
@@ -12689,7 +12689,7 @@
     </p:spTree>
     <p:extLst>
       <p:ext uri="{BB962C8B-B14F-4D97-AF65-F5344CB8AC3E}">
-        <p14:creationId xmlns:p14="http://schemas.microsoft.com/office/powerpoint/2010/main" val="1361935135"/>
+        <p14:creationId xmlns:p14="http://schemas.microsoft.com/office/powerpoint/2010/main" val="1888121117"/>
       </p:ext>
     </p:extLst>
   </p:cSld>

</xml_diff>